<commit_message>
feat: rebuild Holiday Data and AI Camp 2026 materials
</commit_message>
<xml_diff>
--- a/Schools_ML_Track/camp_2026/marketing/editable_flyer_v13/output/School_Track_Registration_Editable.pptx
+++ b/Schools_ML_Track/camp_2026/marketing/editable_flyer_v13/output/School_Track_Registration_Editable.pptx
@@ -3767,7 +3767,7 @@
                 <a:ea typeface="Arial"/>
                 <a:cs typeface="Arial"/>
               </a:rPr>
-              <a:t>Turn real data into</a:t>
+              <a:t>Turn data into</a:t>
             </a:r>
           </a:p>
           <a:p xmlns:a="http://schemas.openxmlformats.org/drawingml/2006/main">
@@ -4080,7 +4080,7 @@
       </p:sp>
       <p:pic>
         <p:nvPicPr>
-          <p:cNvPr id="24" name="">
+          <p:cNvPr id="24" name="Charts logo 349" descr="Charts logo 349">
             <a:extLst xmlns:a="http://schemas.openxmlformats.org/drawingml/2006/main">
               <a:ext uri="{FF2B5EF4-FFF2-40B4-BE49-F238E27FC236}">
                 <a16:creationId xmlns:a16="http://schemas.microsoft.com/office/drawing/2014/main" id="{B696C411-8AC0-40DE-A5A8-88A485B7BD97}"/>
@@ -4093,13 +4093,13 @@
           <p:nvPr/>
         </p:nvPicPr>
         <p:blipFill>
-          <a:blip xmlns:r="http://schemas.openxmlformats.org/officeDocument/2006/relationships" xmlns:a="http://schemas.openxmlformats.org/drawingml/2006/main" r:embed="R3df9a738aa9048a7"/>
+          <a:blip xmlns:r="http://schemas.openxmlformats.org/officeDocument/2006/relationships" xmlns:a="http://schemas.openxmlformats.org/drawingml/2006/main" r:embed="Rb2737346a2ef4f3a"/>
           <a:stretch xmlns:a="http://schemas.openxmlformats.org/drawingml/2006/main"/>
         </p:blipFill>
         <p:spPr>
           <a:xfrm xmlns:a="http://schemas.openxmlformats.org/drawingml/2006/main">
-            <a:off x="3600824" y="7391400"/>
-            <a:ext cx="399301" cy="457200"/>
+            <a:off x="3571875" y="7391400"/>
+            <a:ext cx="457200" cy="457200"/>
           </a:xfrm>
           <a:prstGeom xmlns:a="http://schemas.openxmlformats.org/drawingml/2006/main" prst="rect">
             <a:avLst/>
@@ -4108,7 +4108,7 @@
       </p:pic>
       <p:sp>
         <p:nvSpPr>
-          <p:cNvPr id="25" name="SQL label 349">
+          <p:cNvPr id="25" name="Charts label 349">
             <a:extLst xmlns:a="http://schemas.openxmlformats.org/drawingml/2006/main">
               <a:ext uri="{FF2B5EF4-FFF2-40B4-BE49-F238E27FC236}">
                 <a16:creationId xmlns:a16="http://schemas.microsoft.com/office/drawing/2014/main" id="{98223FC5-43ED-4390-9F1A-35935DB492BD}"/>
@@ -4169,7 +4169,7 @@
                 <a:ea typeface="Arial"/>
                 <a:cs typeface="Arial"/>
               </a:rPr>
-              <a:t>SQL</a:t>
+              <a:t>Charts</a:t>
             </a:r>
           </a:p>
         </p:txBody>
@@ -4805,7 +4805,7 @@
                 <a:ea typeface="Arial"/>
                 <a:cs typeface="Arial"/>
               </a:rPr>
-              <a:t>SQL (querying data)</a:t>
+              <a:t>pandas &amp; NumPy (tables &amp; numbers)</a:t>
             </a:r>
           </a:p>
         </p:txBody>
@@ -5189,7 +5189,7 @@
                 <a:ea typeface="Arial"/>
                 <a:cs typeface="Arial"/>
               </a:rPr>
-              <a:t>Data visualization</a:t>
+              <a:t>Exploration charts</a:t>
             </a:r>
           </a:p>
           <a:p xmlns:a="http://schemas.openxmlformats.org/drawingml/2006/main">
@@ -5212,7 +5212,7 @@
                 <a:ea typeface="Arial"/>
                 <a:cs typeface="Arial"/>
               </a:rPr>
-              <a:t>(dashboards &amp; charts)</a:t>
+              <a:t>(matplotlib &amp; seaborn)</a:t>
             </a:r>
           </a:p>
         </p:txBody>
@@ -5500,7 +5500,7 @@
                 <a:ea typeface="Arial"/>
                 <a:cs typeface="Arial"/>
               </a:rPr>
-              <a:t>Real-world datasets</a:t>
+              <a:t>Testing on unseen data</a:t>
             </a:r>
           </a:p>
         </p:txBody>
@@ -5700,7 +5700,7 @@
                 <a:ea typeface="Arial Narrow"/>
                 <a:cs typeface="Arial Narrow"/>
               </a:rPr>
-              <a:t>e.g. sales, customer or social media data</a:t>
+              <a:t>e.g. shop sales and customer data</a:t>
             </a:r>
           </a:p>
         </p:txBody>
@@ -5836,7 +5836,7 @@
                 <a:ea typeface="Arial Narrow"/>
                 <a:cs typeface="Arial Narrow"/>
               </a:rPr>
-              <a:t>e.g. house prices, classification</a:t>
+              <a:t>e.g. rents, trip fares</a:t>
             </a:r>
           </a:p>
           <a:p xmlns:a="http://schemas.openxmlformats.org/drawingml/2006/main">
@@ -5859,7 +5859,7 @@
                 <a:ea typeface="Arial Narrow"/>
                 <a:cs typeface="Arial Narrow"/>
               </a:rPr>
-              <a:t>or recommendation</a:t>
+              <a:t>or flower species</a:t>
             </a:r>
           </a:p>
         </p:txBody>
@@ -7362,7 +7362,7 @@
                 <a:ea typeface="Arial"/>
                 <a:cs typeface="Arial"/>
               </a:rPr>
-              <a:t>Analysed</a:t>
+              <a:t>Cleaned and</a:t>
             </a:r>
           </a:p>
           <a:p xmlns:a="http://schemas.openxmlformats.org/drawingml/2006/main">
@@ -7385,7 +7385,7 @@
                 <a:ea typeface="Arial"/>
                 <a:cs typeface="Arial"/>
               </a:rPr>
-              <a:t>real datasets</a:t>
+              <a:t>analysed data</a:t>
             </a:r>
           </a:p>
         </p:txBody>

</xml_diff>